<commit_message>
Add speaker notes to Economic Growth deck (PPTX notes + PDF handout)
- Embed simple presenter notes on all 30 slides of the .pptx
  (visible in PowerPoint Presenter View), including click-to-reveal cues.
- Add a printable "Speaker Notes" PDF handout: one page per slide with a
  thumbnail and the notes underneath.

Co-Authored-By: Claude Opus 4.8 <noreply@anthropic.com>
Claude-Session: https://claude.ai/code/session_01KQLJrV9pfPUX7ZE65uxg9s
</commit_message>
<xml_diff>
--- a/Economic_Growth_IB_Economics.pptx
+++ b/Economic_Growth_IB_Economics.pptx
@@ -531,7 +531,7 @@
           <a:p>
             <a:r>
               <a:rPr lang="en-US" dirty="0"/>
-              <a:t/>
+              <a:t>Welcome. Today's topic is economic growth - one of the main macroeconomic objectives. By the end you should be able to define, draw, explain, evaluate and calculate growth (SL and HL). Tip: run this in Slide Show mode - the exercises reveal their answers on click.</a:t>
             </a:r>
             <a:endParaRPr lang="en-US" dirty="0"/>
           </a:p>
@@ -619,7 +619,7 @@
           <a:p>
             <a:r>
               <a:rPr lang="en-US" dirty="0"/>
-              <a:t/>
+              <a:t>Show equilibrium below full capacity. CLICK to shift AD to the right - real GDP rises (actual growth), but so does the price level (inflation risk near full capacity). This is demand-side growth.</a:t>
             </a:r>
             <a:endParaRPr lang="en-US" dirty="0"/>
           </a:p>
@@ -707,7 +707,7 @@
           <a:p>
             <a:r>
               <a:rPr lang="en-US" dirty="0"/>
-              <a:t/>
+              <a:t>CLICK to shift LRAS to the right = potential growth. Capacity rises with no inflationary pressure, so it is sustainable. For stronger students, mention the Keynesian AS version where the vertical section shifts right.</a:t>
             </a:r>
             <a:endParaRPr lang="en-US" dirty="0"/>
           </a:p>
@@ -795,7 +795,7 @@
           <a:p>
             <a:r>
               <a:rPr lang="en-US" dirty="0"/>
-              <a:t/>
+              <a:t>Let students attempt this first. Read the question, pause, then CLICK to reveal the model answer. Reinforce: reopening idle factories = actual growth = a movement inside-to-curve, with no shift of the PPC.</a:t>
             </a:r>
             <a:endParaRPr lang="en-US" dirty="0"/>
           </a:p>
@@ -883,7 +883,7 @@
           <a:p>
             <a:r>
               <a:rPr lang="en-US" dirty="0"/>
-              <a:t/>
+              <a:t>Section 3: what actually causes growth? Two big buckets - more factors, and better factors.</a:t>
             </a:r>
             <a:endParaRPr lang="en-US" dirty="0"/>
           </a:p>
@@ -971,7 +971,7 @@
           <a:p>
             <a:r>
               <a:rPr lang="en-US" dirty="0"/>
-              <a:t/>
+              <a:t>More factors of production: land, labour, capital, enterprise. Each shifts the PPC/LRAS outward. Give a quick real example for each (e.g. a new oil field, immigration).</a:t>
             </a:r>
             <a:endParaRPr lang="en-US" dirty="0"/>
           </a:p>
@@ -1059,7 +1059,7 @@
           <a:p>
             <a:r>
               <a:rPr lang="en-US" dirty="0"/>
-              <a:t/>
+              <a:t>Better, more productive factors: human capital, technology, institutions, and investment (which raises both quantity and quality). Productivity - output per worker - is the real long-run engine.</a:t>
             </a:r>
             <a:endParaRPr lang="en-US" dirty="0"/>
           </a:p>
@@ -1147,7 +1147,7 @@
           <a:p>
             <a:r>
               <a:rPr lang="en-US" dirty="0"/>
-              <a:t/>
+              <a:t>Classification exercise. Read each item, let students call 'quantity' or 'quality', then CLICK to reveal. Watch-outs: training and health = quality; more workers or new land = quantity.</a:t>
             </a:r>
             <a:endParaRPr lang="en-US" dirty="0"/>
           </a:p>
@@ -1235,7 +1235,7 @@
           <a:p>
             <a:r>
               <a:rPr lang="en-US" dirty="0"/>
-              <a:t/>
+              <a:t>Section 4: consequences - the benefits, the costs, and the evaluation examiners reward.</a:t>
             </a:r>
             <a:endParaRPr lang="en-US" dirty="0"/>
           </a:p>
@@ -1323,7 +1323,7 @@
           <a:p>
             <a:r>
               <a:rPr lang="en-US" dirty="0"/>
-              <a:t/>
+              <a:t>Quick run-through of the benefits: higher incomes and living standards, lower unemployment, more tax revenue, less poverty. Students usually know these, so keep it brisk.</a:t>
             </a:r>
             <a:endParaRPr lang="en-US" dirty="0"/>
           </a:p>
@@ -1411,7 +1411,7 @@
           <a:p>
             <a:r>
               <a:rPr lang="en-US" dirty="0"/>
-              <a:t/>
+              <a:t>The flip side: demand-pull inflation, environmental damage, rising inequality, and sustainability concerns. This sets up the evaluation on the next slide.</a:t>
             </a:r>
             <a:endParaRPr lang="en-US" dirty="0"/>
           </a:p>
@@ -1499,7 +1499,7 @@
           <a:p>
             <a:r>
               <a:rPr lang="en-US" dirty="0"/>
-              <a:t/>
+              <a:t>Quick roadmap of the five things we will master. Emphasise that diagrams and evaluation earn the most marks in the exam. Point out the 'Your turn' slides where students try a question before the answer is revealed.</a:t>
             </a:r>
             <a:endParaRPr lang="en-US" dirty="0"/>
           </a:p>
@@ -1587,7 +1587,7 @@
           <a:p>
             <a:r>
               <a:rPr lang="en-US" dirty="0"/>
-              <a:t/>
+              <a:t>The single most important exam skill. Growth is not automatically good - it depends on how it is achieved, who gains, the environmental cost, and the country's context. Drill the exam tip: weigh both sides, use an example, give a judgement.</a:t>
             </a:r>
             <a:endParaRPr lang="en-US" dirty="0"/>
           </a:p>
@@ -1675,7 +1675,7 @@
           <a:p>
             <a:r>
               <a:rPr lang="en-US" dirty="0"/>
-              <a:t/>
+              <a:t>Growth = more output (quantitative). Development = broader wellbeing - incomes plus health, education and freedoms. Growth can enable development but is not the same thing.</a:t>
             </a:r>
             <a:endParaRPr lang="en-US" dirty="0"/>
           </a:p>
@@ -1763,7 +1763,7 @@
           <a:p>
             <a:r>
               <a:rPr lang="en-US" dirty="0"/>
-              <a:t/>
+              <a:t>Section 5: the numbers - the calculation skills the exam expects.</a:t>
             </a:r>
             <a:endParaRPr lang="en-US" dirty="0"/>
           </a:p>
@@ -1851,7 +1851,7 @@
           <a:p>
             <a:r>
               <a:rPr lang="en-US" dirty="0"/>
-              <a:t/>
+              <a:t>Three formulas. The growth-rate formula is the one most tested. Show the deflator conversion and the per-capita formula quickly.</a:t>
             </a:r>
             <a:endParaRPr lang="en-US" dirty="0"/>
           </a:p>
@@ -1939,7 +1939,7 @@
           <a:p>
             <a:r>
               <a:rPr lang="en-US" dirty="0"/>
-              <a:t/>
+              <a:t>Do part (a) live: 30/500 x 100 = 6%. CLICK to reveal. Then part (b): per-capita growth is about 6% - 2% = 4%. Emphasise that the subtraction shortcut works for small percentages, and that living standards rose.</a:t>
             </a:r>
             <a:endParaRPr lang="en-US" dirty="0"/>
           </a:p>
@@ -2027,7 +2027,7 @@
           <a:p>
             <a:r>
               <a:rPr lang="en-US" dirty="0"/>
-              <a:t/>
+              <a:t>Section 6: exam zone - let's test it.</a:t>
             </a:r>
             <a:endParaRPr lang="en-US" dirty="0"/>
           </a:p>
@@ -2115,7 +2115,7 @@
           <a:p>
             <a:r>
               <a:rPr lang="en-US" dirty="0"/>
-              <a:t/>
+              <a:t>Ask each question, let students answer, then CLICK to reveal the correct option. A quick, fun recap of the key definitions and the PPC point.</a:t>
             </a:r>
             <a:endParaRPr lang="en-US" dirty="0"/>
           </a:p>
@@ -2203,7 +2203,7 @@
           <a:p>
             <a:r>
               <a:rPr lang="en-US" dirty="0"/>
-              <a:t/>
+              <a:t>Show how to structure Paper 1 answers. (a) 'Explain' = theory + a diagram + a chain of reasoning + a real example. (b) 'Evaluate' = both sides + a supported judgement. Point out the command terms.</a:t>
             </a:r>
             <a:endParaRPr lang="en-US" dirty="0"/>
           </a:p>
@@ -2291,7 +2291,7 @@
           <a:p>
             <a:r>
               <a:rPr lang="en-US" dirty="0"/>
-              <a:t/>
+              <a:t>A recap of every key term - great for revision. Tell students to cover the right-hand column and test themselves on the definitions.</a:t>
             </a:r>
             <a:endParaRPr lang="en-US" dirty="0"/>
           </a:p>
@@ -2379,7 +2379,7 @@
           <a:p>
             <a:r>
               <a:rPr lang="en-US" dirty="0"/>
-              <a:t/>
+              <a:t>Five takeaways - especially: always evaluate. Point to the 'go further' list for anyone who wants to push beyond the syllabus (HL multiplier, endogenous growth, HDI, green growth).</a:t>
             </a:r>
             <a:endParaRPr lang="en-US" dirty="0"/>
           </a:p>
@@ -2467,7 +2467,7 @@
           <a:p>
             <a:r>
               <a:rPr lang="en-US" dirty="0"/>
-              <a:t/>
+              <a:t>Section 1: the big picture - what economic growth means and how we measure it.</a:t>
             </a:r>
             <a:endParaRPr lang="en-US" dirty="0"/>
           </a:p>
@@ -2555,7 +2555,7 @@
           <a:p>
             <a:r>
               <a:rPr lang="en-US" dirty="0"/>
-              <a:t/>
+              <a:t>Wrap up with the five verbs: define it, draw it, explain it, evaluate it, calculate it. Invite questions. Good luck in the exam!</a:t>
             </a:r>
             <a:endParaRPr lang="en-US" dirty="0"/>
           </a:p>
@@ -2643,7 +2643,7 @@
           <a:p>
             <a:r>
               <a:rPr lang="en-US" dirty="0"/>
-              <a:t/>
+              <a:t>Core definition: an increase in REAL GDP over time. Stress two words: 'real' (adjusted for inflation) and 'per capita' (better for living standards). Remind them growth is one of the macroeconomic objectives.</a:t>
             </a:r>
             <a:endParaRPr lang="en-US" dirty="0"/>
           </a:p>
@@ -2731,7 +2731,7 @@
           <a:p>
             <a:r>
               <a:rPr lang="en-US" dirty="0"/>
-              <a:t/>
+              <a:t>Contrast the two. Nominal GDP uses current prices, so inflation can inflate it. Real GDP uses constant prices, so it shows the true change in volume - that is what we mean by growth. Example: if prices rise but output is flat, nominal rises but real does not.</a:t>
             </a:r>
             <a:endParaRPr lang="en-US" dirty="0"/>
           </a:p>
@@ -2819,7 +2819,7 @@
           <a:p>
             <a:r>
               <a:rPr lang="en-US" dirty="0"/>
-              <a:t/>
+              <a:t>The key distinction for the whole topic. Actual growth = using spare capacity now (short run, closes an output gap). Potential growth = expanding capacity (long run, shifts the frontier). We draw both on the next slides.</a:t>
             </a:r>
             <a:endParaRPr lang="en-US" dirty="0"/>
           </a:p>
@@ -2907,7 +2907,7 @@
           <a:p>
             <a:r>
               <a:rPr lang="en-US" dirty="0"/>
-              <a:t/>
+              <a:t>Growth is the long-run upward trend; the business cycle is the short-run wobble around it. Name the phases (boom, recession, trough, recovery). Define a recession: two consecutive quarters of negative real GDP growth.</a:t>
             </a:r>
             <a:endParaRPr lang="en-US" dirty="0"/>
           </a:p>
@@ -2995,7 +2995,7 @@
           <a:p>
             <a:r>
               <a:rPr lang="en-US" dirty="0"/>
-              <a:t/>
+              <a:t>Section 2: let's put growth on diagrams - the PPC and the AD-AS model.</a:t>
             </a:r>
             <a:endParaRPr lang="en-US" dirty="0"/>
           </a:p>
@@ -3083,7 +3083,7 @@
           <a:p>
             <a:r>
               <a:rPr lang="en-US" dirty="0"/>
-              <a:t/>
+              <a:t>Start with the base PPC. Actual growth = moving from a point inside (A) onto the curve (B) using idle resources. CLICK to reveal potential growth = the whole curve shifting outward. One line to remember: inside-to-curve = actual; whole-curve-out = potential.</a:t>
             </a:r>
             <a:endParaRPr lang="en-US" dirty="0"/>
           </a:p>

</xml_diff>